<commit_message>
Business case: prijspagina met wat de instelling ervoor krijgt
Co-Authored-By: Claude Opus 5.5 <noreply@anthropic.com>
Claude-Session: https://claude.ai/code/session_01N8nwrWExSKGjo2t8Td3eSo
</commit_message>
<xml_diff>
--- a/GTM/Knowledge/business-case/pptx/prijs-bewerkbaar.pptx
+++ b/GTM/Knowledge/business-case/pptx/prijs-bewerkbaar.pptx
@@ -3096,7 +3096,7 @@
         </p:nvSpPr>
         <p:spPr>
           <a:xfrm>
-            <a:off x="762000" y="571500"/>
+            <a:off x="762000" y="444500"/>
             <a:ext cx="10668000" cy="190500"/>
           </a:xfrm>
           <a:prstGeom prst="rect">
@@ -3135,7 +3135,7 @@
         </p:nvSpPr>
         <p:spPr>
           <a:xfrm>
-            <a:off x="762000" y="787400"/>
+            <a:off x="762000" y="660400"/>
             <a:ext cx="10668000" cy="444500"/>
           </a:xfrm>
           <a:prstGeom prst="rect">
@@ -3174,12 +3174,12 @@
         </p:nvSpPr>
         <p:spPr>
           <a:xfrm>
-            <a:off x="762000" y="1587500"/>
-            <a:ext cx="10668000" cy="2730500"/>
+            <a:off x="762000" y="1333500"/>
+            <a:ext cx="10668000" cy="2032000"/>
           </a:xfrm>
           <a:prstGeom prst="roundRect">
             <a:avLst>
-              <a:gd name="adj" fmla="val 6000"/>
+              <a:gd name="adj" fmla="val 7000"/>
             </a:avLst>
           </a:prstGeom>
           <a:solidFill>
@@ -3220,8 +3220,8 @@
         </p:nvSpPr>
         <p:spPr>
           <a:xfrm>
-            <a:off x="1333500" y="1587500"/>
-            <a:ext cx="9525000" cy="2730500"/>
+            <a:off x="1333500" y="1333500"/>
+            <a:ext cx="9525000" cy="2032000"/>
           </a:xfrm>
           <a:prstGeom prst="rect">
             <a:avLst/>
@@ -3240,7 +3240,7 @@
               </a:spcBef>
             </a:pPr>
             <a:r>
-              <a:rPr sz="9600" b="1">
+              <a:rPr sz="6800" b="1">
                 <a:solidFill>
                   <a:srgbClr val="FFFFFF"/>
                 </a:solidFill>
@@ -3252,11 +3252,11 @@
           <a:p>
             <a:pPr>
               <a:spcBef>
-                <a:spcPts val="1000"/>
+                <a:spcPts val="800"/>
               </a:spcBef>
             </a:pPr>
             <a:r>
-              <a:rPr sz="2200" b="0">
+              <a:rPr sz="2000" b="0">
                 <a:solidFill>
                   <a:srgbClr val="FFFFFF"/>
                 </a:solidFill>
@@ -3268,11 +3268,11 @@
           <a:p>
             <a:pPr>
               <a:spcBef>
-                <a:spcPts val="600"/>
+                <a:spcPts val="400"/>
               </a:spcBef>
             </a:pPr>
             <a:r>
-              <a:rPr sz="1500" b="0">
+              <a:rPr sz="1400" b="0">
                 <a:solidFill>
                   <a:srgbClr val="C9CED9"/>
                 </a:solidFill>
@@ -3291,12 +3291,12 @@
         </p:nvSpPr>
         <p:spPr>
           <a:xfrm>
-            <a:off x="762000" y="4495800"/>
-            <a:ext cx="5257800" cy="1206500"/>
+            <a:off x="762000" y="3479800"/>
+            <a:ext cx="5257800" cy="787400"/>
           </a:xfrm>
           <a:prstGeom prst="roundRect">
             <a:avLst>
-              <a:gd name="adj" fmla="val 10000"/>
+              <a:gd name="adj" fmla="val 12000"/>
             </a:avLst>
           </a:prstGeom>
           <a:solidFill>
@@ -3337,8 +3337,8 @@
         </p:nvSpPr>
         <p:spPr>
           <a:xfrm>
-            <a:off x="1041400" y="4495800"/>
-            <a:ext cx="4699000" cy="1206500"/>
+            <a:off x="1041400" y="3479800"/>
+            <a:ext cx="4699000" cy="787400"/>
           </a:xfrm>
           <a:prstGeom prst="rect">
             <a:avLst/>
@@ -3357,7 +3357,7 @@
               </a:spcBef>
             </a:pPr>
             <a:r>
-              <a:rPr sz="2200" b="1">
+              <a:rPr sz="1800" b="1">
                 <a:solidFill>
                   <a:srgbClr val="0B1533"/>
                 </a:solidFill>
@@ -3369,11 +3369,11 @@
           <a:p>
             <a:pPr>
               <a:spcBef>
-                <a:spcPts val="600"/>
+                <a:spcPts val="400"/>
               </a:spcBef>
             </a:pPr>
             <a:r>
-              <a:rPr sz="1400" b="0">
+              <a:rPr sz="1300" b="0">
                 <a:solidFill>
                   <a:srgbClr val="1D2433"/>
                 </a:solidFill>
@@ -3392,12 +3392,12 @@
         </p:nvSpPr>
         <p:spPr>
           <a:xfrm>
-            <a:off x="6172200" y="4495800"/>
-            <a:ext cx="5257800" cy="1206500"/>
+            <a:off x="6172200" y="3479800"/>
+            <a:ext cx="5257800" cy="787400"/>
           </a:xfrm>
           <a:prstGeom prst="roundRect">
             <a:avLst>
-              <a:gd name="adj" fmla="val 10000"/>
+              <a:gd name="adj" fmla="val 12000"/>
             </a:avLst>
           </a:prstGeom>
           <a:solidFill>
@@ -3438,8 +3438,8 @@
         </p:nvSpPr>
         <p:spPr>
           <a:xfrm>
-            <a:off x="6451600" y="4495800"/>
-            <a:ext cx="4699000" cy="1206500"/>
+            <a:off x="6451600" y="3479800"/>
+            <a:ext cx="4699000" cy="787400"/>
           </a:xfrm>
           <a:prstGeom prst="rect">
             <a:avLst/>
@@ -3458,7 +3458,7 @@
               </a:spcBef>
             </a:pPr>
             <a:r>
-              <a:rPr sz="2200" b="1">
+              <a:rPr sz="1800" b="1">
                 <a:solidFill>
                   <a:srgbClr val="0B1533"/>
                 </a:solidFill>
@@ -3470,17 +3470,569 @@
           <a:p>
             <a:pPr>
               <a:spcBef>
-                <a:spcPts val="600"/>
+                <a:spcPts val="400"/>
               </a:spcBef>
             </a:pPr>
             <a:r>
-              <a:rPr sz="1400" b="0">
+              <a:rPr sz="1300" b="0">
                 <a:solidFill>
                   <a:srgbClr val="1D2433"/>
                 </a:solidFill>
                 <a:latin typeface="Inter"/>
               </a:rPr>
               <a:t>€ 3 per student per maand</a:t>
+            </a:r>
+          </a:p>
+        </p:txBody>
+      </p:sp>
+      <p:sp>
+        <p:nvSpPr>
+          <p:cNvPr id="10" name="TextBox 9"/>
+          <p:cNvSpPr txBox="1"/>
+          <p:nvPr/>
+        </p:nvSpPr>
+        <p:spPr>
+          <a:xfrm>
+            <a:off x="762000" y="4521200"/>
+            <a:ext cx="10668000" cy="190500"/>
+          </a:xfrm>
+          <a:prstGeom prst="rect">
+            <a:avLst/>
+          </a:prstGeom>
+          <a:noFill/>
+        </p:spPr>
+        <p:txBody>
+          <a:bodyPr wrap="square" anchor="t" lIns="0" rIns="0" tIns="0" bIns="0">
+            <a:spAutoFit/>
+          </a:bodyPr>
+          <a:lstStyle/>
+          <a:p>
+            <a:pPr>
+              <a:spcBef>
+                <a:spcPts val="0"/>
+              </a:spcBef>
+            </a:pPr>
+            <a:r>
+              <a:rPr sz="1100" b="1">
+                <a:solidFill>
+                  <a:srgbClr val="0B1533"/>
+                </a:solidFill>
+                <a:latin typeface="Inter"/>
+              </a:rPr>
+              <a:t>WAT DE INSTELLING ERVOOR KRIJGT</a:t>
+            </a:r>
+          </a:p>
+        </p:txBody>
+      </p:sp>
+      <p:sp>
+        <p:nvSpPr>
+          <p:cNvPr id="11" name="Rounded Rectangle 10"/>
+          <p:cNvSpPr/>
+          <p:nvPr/>
+        </p:nvSpPr>
+        <p:spPr>
+          <a:xfrm>
+            <a:off x="762000" y="4775200"/>
+            <a:ext cx="3454400" cy="1714500"/>
+          </a:xfrm>
+          <a:prstGeom prst="roundRect">
+            <a:avLst>
+              <a:gd name="adj" fmla="val 8000"/>
+            </a:avLst>
+          </a:prstGeom>
+          <a:solidFill>
+            <a:srgbClr val="FFFFFF"/>
+          </a:solidFill>
+          <a:ln w="12700">
+            <a:solidFill>
+              <a:srgbClr val="D9DDE4"/>
+            </a:solidFill>
+          </a:ln>
+          <a:effectLst/>
+        </p:spPr>
+        <p:style>
+          <a:lnRef idx="1">
+            <a:schemeClr val="accent1"/>
+          </a:lnRef>
+          <a:fillRef idx="3">
+            <a:schemeClr val="accent1"/>
+          </a:fillRef>
+          <a:effectRef idx="2">
+            <a:schemeClr val="accent1"/>
+          </a:effectRef>
+          <a:fontRef idx="minor">
+            <a:schemeClr val="lt1"/>
+          </a:fontRef>
+        </p:style>
+        <p:txBody>
+          <a:bodyPr rtlCol="0" anchor="ctr"/>
+          <a:lstStyle/>
+          <a:p>
+            <a:pPr algn="ctr"/>
+          </a:p>
+        </p:txBody>
+      </p:sp>
+      <p:sp>
+        <p:nvSpPr>
+          <p:cNvPr id="12" name="Oval 11"/>
+          <p:cNvSpPr/>
+          <p:nvPr/>
+        </p:nvSpPr>
+        <p:spPr>
+          <a:xfrm>
+            <a:off x="990600" y="5003800"/>
+            <a:ext cx="457200" cy="457200"/>
+          </a:xfrm>
+          <a:prstGeom prst="ellipse">
+            <a:avLst/>
+          </a:prstGeom>
+          <a:solidFill>
+            <a:srgbClr val="EEF1F7"/>
+          </a:solidFill>
+          <a:ln>
+            <a:noFill/>
+          </a:ln>
+          <a:effectLst/>
+        </p:spPr>
+        <p:style>
+          <a:lnRef idx="1">
+            <a:schemeClr val="accent1"/>
+          </a:lnRef>
+          <a:fillRef idx="3">
+            <a:schemeClr val="accent1"/>
+          </a:fillRef>
+          <a:effectRef idx="2">
+            <a:schemeClr val="accent1"/>
+          </a:effectRef>
+          <a:fontRef idx="minor">
+            <a:schemeClr val="lt1"/>
+          </a:fontRef>
+        </p:style>
+        <p:txBody>
+          <a:bodyPr rtlCol="0" anchor="ctr"/>
+          <a:lstStyle/>
+          <a:p>
+            <a:pPr algn="ctr"/>
+          </a:p>
+        </p:txBody>
+      </p:sp>
+      <p:pic>
+        <p:nvPicPr>
+          <p:cNvPr id="13" name="Picture 12" descr="consistent.png"/>
+          <p:cNvPicPr>
+            <a:picLocks noChangeAspect="1"/>
+          </p:cNvPicPr>
+          <p:nvPr/>
+        </p:nvPicPr>
+        <p:blipFill>
+          <a:blip r:embed="rId2"/>
+          <a:stretch>
+            <a:fillRect/>
+          </a:stretch>
+        </p:blipFill>
+        <p:spPr>
+          <a:xfrm>
+            <a:off x="1092200" y="5105400"/>
+            <a:ext cx="254000" cy="254000"/>
+          </a:xfrm>
+          <a:prstGeom prst="rect">
+            <a:avLst/>
+          </a:prstGeom>
+        </p:spPr>
+      </p:pic>
+      <p:sp>
+        <p:nvSpPr>
+          <p:cNvPr id="14" name="TextBox 13"/>
+          <p:cNvSpPr txBox="1"/>
+          <p:nvPr/>
+        </p:nvSpPr>
+        <p:spPr>
+          <a:xfrm>
+            <a:off x="990600" y="5588000"/>
+            <a:ext cx="2997200" cy="825500"/>
+          </a:xfrm>
+          <a:prstGeom prst="rect">
+            <a:avLst/>
+          </a:prstGeom>
+          <a:noFill/>
+        </p:spPr>
+        <p:txBody>
+          <a:bodyPr wrap="square" anchor="t" lIns="0" rIns="0" tIns="0" bIns="0">
+            <a:spAutoFit/>
+          </a:bodyPr>
+          <a:lstStyle/>
+          <a:p>
+            <a:pPr>
+              <a:spcBef>
+                <a:spcPts val="0"/>
+              </a:spcBef>
+            </a:pPr>
+            <a:r>
+              <a:rPr sz="1600" b="1">
+                <a:solidFill>
+                  <a:srgbClr val="1D2433"/>
+                </a:solidFill>
+                <a:latin typeface="Inter"/>
+              </a:rPr>
+              <a:t>Uniforme beoordeling</a:t>
+            </a:r>
+          </a:p>
+          <a:p>
+            <a:pPr>
+              <a:spcBef>
+                <a:spcPts val="400"/>
+              </a:spcBef>
+            </a:pPr>
+            <a:r>
+              <a:rPr sz="1200" b="0">
+                <a:solidFill>
+                  <a:srgbClr val="1D2433"/>
+                </a:solidFill>
+                <a:latin typeface="Inter"/>
+              </a:rPr>
+              <a:t>Elke opdracht wordt langs dezelfde criteria beoordeeld, door elke beoordelaar.</a:t>
+            </a:r>
+          </a:p>
+        </p:txBody>
+      </p:sp>
+      <p:sp>
+        <p:nvSpPr>
+          <p:cNvPr id="15" name="Rounded Rectangle 14"/>
+          <p:cNvSpPr/>
+          <p:nvPr/>
+        </p:nvSpPr>
+        <p:spPr>
+          <a:xfrm>
+            <a:off x="4368800" y="4775200"/>
+            <a:ext cx="3454400" cy="1714500"/>
+          </a:xfrm>
+          <a:prstGeom prst="roundRect">
+            <a:avLst>
+              <a:gd name="adj" fmla="val 8000"/>
+            </a:avLst>
+          </a:prstGeom>
+          <a:solidFill>
+            <a:srgbClr val="FFFFFF"/>
+          </a:solidFill>
+          <a:ln w="12700">
+            <a:solidFill>
+              <a:srgbClr val="D9DDE4"/>
+            </a:solidFill>
+          </a:ln>
+          <a:effectLst/>
+        </p:spPr>
+        <p:style>
+          <a:lnRef idx="1">
+            <a:schemeClr val="accent1"/>
+          </a:lnRef>
+          <a:fillRef idx="3">
+            <a:schemeClr val="accent1"/>
+          </a:fillRef>
+          <a:effectRef idx="2">
+            <a:schemeClr val="accent1"/>
+          </a:effectRef>
+          <a:fontRef idx="minor">
+            <a:schemeClr val="lt1"/>
+          </a:fontRef>
+        </p:style>
+        <p:txBody>
+          <a:bodyPr rtlCol="0" anchor="ctr"/>
+          <a:lstStyle/>
+          <a:p>
+            <a:pPr algn="ctr"/>
+          </a:p>
+        </p:txBody>
+      </p:sp>
+      <p:sp>
+        <p:nvSpPr>
+          <p:cNvPr id="16" name="Oval 15"/>
+          <p:cNvSpPr/>
+          <p:nvPr/>
+        </p:nvSpPr>
+        <p:spPr>
+          <a:xfrm>
+            <a:off x="4597400" y="5003800"/>
+            <a:ext cx="457200" cy="457200"/>
+          </a:xfrm>
+          <a:prstGeom prst="ellipse">
+            <a:avLst/>
+          </a:prstGeom>
+          <a:solidFill>
+            <a:srgbClr val="EEF1F7"/>
+          </a:solidFill>
+          <a:ln>
+            <a:noFill/>
+          </a:ln>
+          <a:effectLst/>
+        </p:spPr>
+        <p:style>
+          <a:lnRef idx="1">
+            <a:schemeClr val="accent1"/>
+          </a:lnRef>
+          <a:fillRef idx="3">
+            <a:schemeClr val="accent1"/>
+          </a:fillRef>
+          <a:effectRef idx="2">
+            <a:schemeClr val="accent1"/>
+          </a:effectRef>
+          <a:fontRef idx="minor">
+            <a:schemeClr val="lt1"/>
+          </a:fontRef>
+        </p:style>
+        <p:txBody>
+          <a:bodyPr rtlCol="0" anchor="ctr"/>
+          <a:lstStyle/>
+          <a:p>
+            <a:pPr algn="ctr"/>
+          </a:p>
+        </p:txBody>
+      </p:sp>
+      <p:pic>
+        <p:nvPicPr>
+          <p:cNvPr id="17" name="Picture 16" descr="koppeling.png"/>
+          <p:cNvPicPr>
+            <a:picLocks noChangeAspect="1"/>
+          </p:cNvPicPr>
+          <p:nvPr/>
+        </p:nvPicPr>
+        <p:blipFill>
+          <a:blip r:embed="rId3"/>
+          <a:stretch>
+            <a:fillRect/>
+          </a:stretch>
+        </p:blipFill>
+        <p:spPr>
+          <a:xfrm>
+            <a:off x="4699000" y="5105400"/>
+            <a:ext cx="254000" cy="254000"/>
+          </a:xfrm>
+          <a:prstGeom prst="rect">
+            <a:avLst/>
+          </a:prstGeom>
+        </p:spPr>
+      </p:pic>
+      <p:sp>
+        <p:nvSpPr>
+          <p:cNvPr id="18" name="TextBox 17"/>
+          <p:cNvSpPr txBox="1"/>
+          <p:nvPr/>
+        </p:nvSpPr>
+        <p:spPr>
+          <a:xfrm>
+            <a:off x="4597400" y="5588000"/>
+            <a:ext cx="2997200" cy="825500"/>
+          </a:xfrm>
+          <a:prstGeom prst="rect">
+            <a:avLst/>
+          </a:prstGeom>
+          <a:noFill/>
+        </p:spPr>
+        <p:txBody>
+          <a:bodyPr wrap="square" anchor="t" lIns="0" rIns="0" tIns="0" bIns="0">
+            <a:spAutoFit/>
+          </a:bodyPr>
+          <a:lstStyle/>
+          <a:p>
+            <a:pPr>
+              <a:spcBef>
+                <a:spcPts val="0"/>
+              </a:spcBef>
+            </a:pPr>
+            <a:r>
+              <a:rPr sz="1600" b="1">
+                <a:solidFill>
+                  <a:srgbClr val="1D2433"/>
+                </a:solidFill>
+                <a:latin typeface="Inter"/>
+              </a:rPr>
+              <a:t>Integratie in NEO LMS</a:t>
+            </a:r>
+          </a:p>
+          <a:p>
+            <a:pPr>
+              <a:spcBef>
+                <a:spcPts val="400"/>
+              </a:spcBef>
+            </a:pPr>
+            <a:r>
+              <a:rPr sz="1200" b="0">
+                <a:solidFill>
+                  <a:srgbClr val="1D2433"/>
+                </a:solidFill>
+                <a:latin typeface="Inter"/>
+              </a:rPr>
+              <a:t>Opdrachten en cijfers lopen via NEO. Docenten en studenten werken in de omgeving die ze kennen.</a:t>
+            </a:r>
+          </a:p>
+        </p:txBody>
+      </p:sp>
+      <p:sp>
+        <p:nvSpPr>
+          <p:cNvPr id="19" name="Rounded Rectangle 18"/>
+          <p:cNvSpPr/>
+          <p:nvPr/>
+        </p:nvSpPr>
+        <p:spPr>
+          <a:xfrm>
+            <a:off x="7975600" y="4775200"/>
+            <a:ext cx="3454400" cy="1714500"/>
+          </a:xfrm>
+          <a:prstGeom prst="roundRect">
+            <a:avLst>
+              <a:gd name="adj" fmla="val 8000"/>
+            </a:avLst>
+          </a:prstGeom>
+          <a:solidFill>
+            <a:srgbClr val="FFFFFF"/>
+          </a:solidFill>
+          <a:ln w="12700">
+            <a:solidFill>
+              <a:srgbClr val="D9DDE4"/>
+            </a:solidFill>
+          </a:ln>
+          <a:effectLst/>
+        </p:spPr>
+        <p:style>
+          <a:lnRef idx="1">
+            <a:schemeClr val="accent1"/>
+          </a:lnRef>
+          <a:fillRef idx="3">
+            <a:schemeClr val="accent1"/>
+          </a:fillRef>
+          <a:effectRef idx="2">
+            <a:schemeClr val="accent1"/>
+          </a:effectRef>
+          <a:fontRef idx="minor">
+            <a:schemeClr val="lt1"/>
+          </a:fontRef>
+        </p:style>
+        <p:txBody>
+          <a:bodyPr rtlCol="0" anchor="ctr"/>
+          <a:lstStyle/>
+          <a:p>
+            <a:pPr algn="ctr"/>
+          </a:p>
+        </p:txBody>
+      </p:sp>
+      <p:sp>
+        <p:nvSpPr>
+          <p:cNvPr id="20" name="Oval 19"/>
+          <p:cNvSpPr/>
+          <p:nvPr/>
+        </p:nvSpPr>
+        <p:spPr>
+          <a:xfrm>
+            <a:off x="8204200" y="5003800"/>
+            <a:ext cx="457200" cy="457200"/>
+          </a:xfrm>
+          <a:prstGeom prst="ellipse">
+            <a:avLst/>
+          </a:prstGeom>
+          <a:solidFill>
+            <a:srgbClr val="EEF1F7"/>
+          </a:solidFill>
+          <a:ln>
+            <a:noFill/>
+          </a:ln>
+          <a:effectLst/>
+        </p:spPr>
+        <p:style>
+          <a:lnRef idx="1">
+            <a:schemeClr val="accent1"/>
+          </a:lnRef>
+          <a:fillRef idx="3">
+            <a:schemeClr val="accent1"/>
+          </a:fillRef>
+          <a:effectRef idx="2">
+            <a:schemeClr val="accent1"/>
+          </a:effectRef>
+          <a:fontRef idx="minor">
+            <a:schemeClr val="lt1"/>
+          </a:fontRef>
+        </p:style>
+        <p:txBody>
+          <a:bodyPr rtlCol="0" anchor="ctr"/>
+          <a:lstStyle/>
+          <a:p>
+            <a:pPr algn="ctr"/>
+          </a:p>
+        </p:txBody>
+      </p:sp>
+      <p:pic>
+        <p:nvPicPr>
+          <p:cNvPr id="21" name="Picture 20" descr="feedback.png"/>
+          <p:cNvPicPr>
+            <a:picLocks noChangeAspect="1"/>
+          </p:cNvPicPr>
+          <p:nvPr/>
+        </p:nvPicPr>
+        <p:blipFill>
+          <a:blip r:embed="rId4"/>
+          <a:stretch>
+            <a:fillRect/>
+          </a:stretch>
+        </p:blipFill>
+        <p:spPr>
+          <a:xfrm>
+            <a:off x="8305800" y="5105400"/>
+            <a:ext cx="254000" cy="254000"/>
+          </a:xfrm>
+          <a:prstGeom prst="rect">
+            <a:avLst/>
+          </a:prstGeom>
+        </p:spPr>
+      </p:pic>
+      <p:sp>
+        <p:nvSpPr>
+          <p:cNvPr id="22" name="TextBox 21"/>
+          <p:cNvSpPr txBox="1"/>
+          <p:nvPr/>
+        </p:nvSpPr>
+        <p:spPr>
+          <a:xfrm>
+            <a:off x="8204200" y="5588000"/>
+            <a:ext cx="2997200" cy="825500"/>
+          </a:xfrm>
+          <a:prstGeom prst="rect">
+            <a:avLst/>
+          </a:prstGeom>
+          <a:noFill/>
+        </p:spPr>
+        <p:txBody>
+          <a:bodyPr wrap="square" anchor="t" lIns="0" rIns="0" tIns="0" bIns="0">
+            <a:spAutoFit/>
+          </a:bodyPr>
+          <a:lstStyle/>
+          <a:p>
+            <a:pPr>
+              <a:spcBef>
+                <a:spcPts val="0"/>
+              </a:spcBef>
+            </a:pPr>
+            <a:r>
+              <a:rPr sz="1600" b="1">
+                <a:solidFill>
+                  <a:srgbClr val="1D2433"/>
+                </a:solidFill>
+                <a:latin typeface="Inter"/>
+              </a:rPr>
+              <a:t>Formatieve feedback van 50% naar 100%</a:t>
+            </a:r>
+          </a:p>
+          <a:p>
+            <a:pPr>
+              <a:spcBef>
+                <a:spcPts val="400"/>
+              </a:spcBef>
+            </a:pPr>
+            <a:r>
+              <a:rPr sz="1200" b="0">
+                <a:solidFill>
+                  <a:srgbClr val="1D2433"/>
+                </a:solidFill>
+                <a:latin typeface="Inter"/>
+              </a:rPr>
+              <a:t>Elke student krijgt formatieve feedback. Nu is dat de helft.</a:t>
             </a:r>
           </a:p>
         </p:txBody>

</xml_diff>

<commit_message>
Business case: voordelen op prijspagina verticaal
Co-Authored-By: Claude Opus 5.5 <noreply@anthropic.com>
Claude-Session: https://claude.ai/code/session_01N8nwrWExSKGjo2t8Td3eSo
</commit_message>
<xml_diff>
--- a/GTM/Knowledge/business-case/pptx/prijs-bewerkbaar.pptx
+++ b/GTM/Knowledge/business-case/pptx/prijs-bewerkbaar.pptx
@@ -3532,12 +3532,12 @@
         </p:nvSpPr>
         <p:spPr>
           <a:xfrm>
-            <a:off x="762000" y="4775200"/>
-            <a:ext cx="3454400" cy="1714500"/>
+            <a:off x="762000" y="4749800"/>
+            <a:ext cx="10668000" cy="533400"/>
           </a:xfrm>
           <a:prstGeom prst="roundRect">
             <a:avLst>
-              <a:gd name="adj" fmla="val 8000"/>
+              <a:gd name="adj" fmla="val 18000"/>
             </a:avLst>
           </a:prstGeom>
           <a:solidFill>
@@ -3580,8 +3580,8 @@
         </p:nvSpPr>
         <p:spPr>
           <a:xfrm>
-            <a:off x="990600" y="5003800"/>
-            <a:ext cx="457200" cy="457200"/>
+            <a:off x="914400" y="4838700"/>
+            <a:ext cx="355600" cy="355600"/>
           </a:xfrm>
           <a:prstGeom prst="ellipse">
             <a:avLst/>
@@ -3632,8 +3632,8 @@
         </p:blipFill>
         <p:spPr>
           <a:xfrm>
-            <a:off x="1092200" y="5105400"/>
-            <a:ext cx="254000" cy="254000"/>
+            <a:off x="1003300" y="4927600"/>
+            <a:ext cx="177800" cy="177800"/>
           </a:xfrm>
           <a:prstGeom prst="rect">
             <a:avLst/>
@@ -3648,8 +3648,8 @@
         </p:nvSpPr>
         <p:spPr>
           <a:xfrm>
-            <a:off x="990600" y="5588000"/>
-            <a:ext cx="2997200" cy="825500"/>
+            <a:off x="1447800" y="4749800"/>
+            <a:ext cx="4191000" cy="533400"/>
           </a:xfrm>
           <a:prstGeom prst="rect">
             <a:avLst/>
@@ -3657,7 +3657,7 @@
           <a:noFill/>
         </p:spPr>
         <p:txBody>
-          <a:bodyPr wrap="square" anchor="t" lIns="0" rIns="0" tIns="0" bIns="0">
+          <a:bodyPr wrap="square" anchor="ctr" lIns="0" rIns="0" tIns="0" bIns="0">
             <a:spAutoFit/>
           </a:bodyPr>
           <a:lstStyle/>
@@ -3677,14 +3677,37 @@
               <a:t>Uniforme beoordeling</a:t>
             </a:r>
           </a:p>
+        </p:txBody>
+      </p:sp>
+      <p:sp>
+        <p:nvSpPr>
+          <p:cNvPr id="15" name="TextBox 14"/>
+          <p:cNvSpPr txBox="1"/>
+          <p:nvPr/>
+        </p:nvSpPr>
+        <p:spPr>
+          <a:xfrm>
+            <a:off x="5778500" y="4749800"/>
+            <a:ext cx="5461000" cy="533400"/>
+          </a:xfrm>
+          <a:prstGeom prst="rect">
+            <a:avLst/>
+          </a:prstGeom>
+          <a:noFill/>
+        </p:spPr>
+        <p:txBody>
+          <a:bodyPr wrap="square" anchor="ctr" lIns="0" rIns="0" tIns="0" bIns="0">
+            <a:spAutoFit/>
+          </a:bodyPr>
+          <a:lstStyle/>
           <a:p>
             <a:pPr>
               <a:spcBef>
-                <a:spcPts val="400"/>
+                <a:spcPts val="0"/>
               </a:spcBef>
             </a:pPr>
             <a:r>
-              <a:rPr sz="1200" b="0">
+              <a:rPr sz="1300" b="0">
                 <a:solidFill>
                   <a:srgbClr val="1D2433"/>
                 </a:solidFill>
@@ -3697,18 +3720,18 @@
       </p:sp>
       <p:sp>
         <p:nvSpPr>
-          <p:cNvPr id="15" name="Rounded Rectangle 14"/>
+          <p:cNvPr id="16" name="Rounded Rectangle 15"/>
           <p:cNvSpPr/>
           <p:nvPr/>
         </p:nvSpPr>
         <p:spPr>
           <a:xfrm>
-            <a:off x="4368800" y="4775200"/>
-            <a:ext cx="3454400" cy="1714500"/>
+            <a:off x="762000" y="5359400"/>
+            <a:ext cx="10668000" cy="533400"/>
           </a:xfrm>
           <a:prstGeom prst="roundRect">
             <a:avLst>
-              <a:gd name="adj" fmla="val 8000"/>
+              <a:gd name="adj" fmla="val 18000"/>
             </a:avLst>
           </a:prstGeom>
           <a:solidFill>
@@ -3745,14 +3768,14 @@
       </p:sp>
       <p:sp>
         <p:nvSpPr>
-          <p:cNvPr id="16" name="Oval 15"/>
+          <p:cNvPr id="17" name="Oval 16"/>
           <p:cNvSpPr/>
           <p:nvPr/>
         </p:nvSpPr>
         <p:spPr>
           <a:xfrm>
-            <a:off x="4597400" y="5003800"/>
-            <a:ext cx="457200" cy="457200"/>
+            <a:off x="914400" y="5448300"/>
+            <a:ext cx="355600" cy="355600"/>
           </a:xfrm>
           <a:prstGeom prst="ellipse">
             <a:avLst/>
@@ -3789,7 +3812,7 @@
       </p:sp>
       <p:pic>
         <p:nvPicPr>
-          <p:cNvPr id="17" name="Picture 16" descr="koppeling.png"/>
+          <p:cNvPr id="18" name="Picture 17" descr="koppeling.png"/>
           <p:cNvPicPr>
             <a:picLocks noChangeAspect="1"/>
           </p:cNvPicPr>
@@ -3803,8 +3826,8 @@
         </p:blipFill>
         <p:spPr>
           <a:xfrm>
-            <a:off x="4699000" y="5105400"/>
-            <a:ext cx="254000" cy="254000"/>
+            <a:off x="1003300" y="5537200"/>
+            <a:ext cx="177800" cy="177800"/>
           </a:xfrm>
           <a:prstGeom prst="rect">
             <a:avLst/>
@@ -3813,14 +3836,14 @@
       </p:pic>
       <p:sp>
         <p:nvSpPr>
-          <p:cNvPr id="18" name="TextBox 17"/>
+          <p:cNvPr id="19" name="TextBox 18"/>
           <p:cNvSpPr txBox="1"/>
           <p:nvPr/>
         </p:nvSpPr>
         <p:spPr>
           <a:xfrm>
-            <a:off x="4597400" y="5588000"/>
-            <a:ext cx="2997200" cy="825500"/>
+            <a:off x="1447800" y="5359400"/>
+            <a:ext cx="4191000" cy="533400"/>
           </a:xfrm>
           <a:prstGeom prst="rect">
             <a:avLst/>
@@ -3828,7 +3851,7 @@
           <a:noFill/>
         </p:spPr>
         <p:txBody>
-          <a:bodyPr wrap="square" anchor="t" lIns="0" rIns="0" tIns="0" bIns="0">
+          <a:bodyPr wrap="square" anchor="ctr" lIns="0" rIns="0" tIns="0" bIns="0">
             <a:spAutoFit/>
           </a:bodyPr>
           <a:lstStyle/>
@@ -3848,14 +3871,37 @@
               <a:t>Integratie in NEO LMS</a:t>
             </a:r>
           </a:p>
+        </p:txBody>
+      </p:sp>
+      <p:sp>
+        <p:nvSpPr>
+          <p:cNvPr id="20" name="TextBox 19"/>
+          <p:cNvSpPr txBox="1"/>
+          <p:nvPr/>
+        </p:nvSpPr>
+        <p:spPr>
+          <a:xfrm>
+            <a:off x="5778500" y="5359400"/>
+            <a:ext cx="5461000" cy="533400"/>
+          </a:xfrm>
+          <a:prstGeom prst="rect">
+            <a:avLst/>
+          </a:prstGeom>
+          <a:noFill/>
+        </p:spPr>
+        <p:txBody>
+          <a:bodyPr wrap="square" anchor="ctr" lIns="0" rIns="0" tIns="0" bIns="0">
+            <a:spAutoFit/>
+          </a:bodyPr>
+          <a:lstStyle/>
           <a:p>
             <a:pPr>
               <a:spcBef>
-                <a:spcPts val="400"/>
+                <a:spcPts val="0"/>
               </a:spcBef>
             </a:pPr>
             <a:r>
-              <a:rPr sz="1200" b="0">
+              <a:rPr sz="1300" b="0">
                 <a:solidFill>
                   <a:srgbClr val="1D2433"/>
                 </a:solidFill>
@@ -3868,18 +3914,18 @@
       </p:sp>
       <p:sp>
         <p:nvSpPr>
-          <p:cNvPr id="19" name="Rounded Rectangle 18"/>
+          <p:cNvPr id="21" name="Rounded Rectangle 20"/>
           <p:cNvSpPr/>
           <p:nvPr/>
         </p:nvSpPr>
         <p:spPr>
           <a:xfrm>
-            <a:off x="7975600" y="4775200"/>
-            <a:ext cx="3454400" cy="1714500"/>
+            <a:off x="762000" y="5969000"/>
+            <a:ext cx="10668000" cy="533400"/>
           </a:xfrm>
           <a:prstGeom prst="roundRect">
             <a:avLst>
-              <a:gd name="adj" fmla="val 8000"/>
+              <a:gd name="adj" fmla="val 18000"/>
             </a:avLst>
           </a:prstGeom>
           <a:solidFill>
@@ -3916,14 +3962,14 @@
       </p:sp>
       <p:sp>
         <p:nvSpPr>
-          <p:cNvPr id="20" name="Oval 19"/>
+          <p:cNvPr id="22" name="Oval 21"/>
           <p:cNvSpPr/>
           <p:nvPr/>
         </p:nvSpPr>
         <p:spPr>
           <a:xfrm>
-            <a:off x="8204200" y="5003800"/>
-            <a:ext cx="457200" cy="457200"/>
+            <a:off x="914400" y="6057900"/>
+            <a:ext cx="355600" cy="355600"/>
           </a:xfrm>
           <a:prstGeom prst="ellipse">
             <a:avLst/>
@@ -3960,7 +4006,7 @@
       </p:sp>
       <p:pic>
         <p:nvPicPr>
-          <p:cNvPr id="21" name="Picture 20" descr="feedback.png"/>
+          <p:cNvPr id="23" name="Picture 22" descr="feedback.png"/>
           <p:cNvPicPr>
             <a:picLocks noChangeAspect="1"/>
           </p:cNvPicPr>
@@ -3974,8 +4020,8 @@
         </p:blipFill>
         <p:spPr>
           <a:xfrm>
-            <a:off x="8305800" y="5105400"/>
-            <a:ext cx="254000" cy="254000"/>
+            <a:off x="1003300" y="6146800"/>
+            <a:ext cx="177800" cy="177800"/>
           </a:xfrm>
           <a:prstGeom prst="rect">
             <a:avLst/>
@@ -3984,14 +4030,14 @@
       </p:pic>
       <p:sp>
         <p:nvSpPr>
-          <p:cNvPr id="22" name="TextBox 21"/>
+          <p:cNvPr id="24" name="TextBox 23"/>
           <p:cNvSpPr txBox="1"/>
           <p:nvPr/>
         </p:nvSpPr>
         <p:spPr>
           <a:xfrm>
-            <a:off x="8204200" y="5588000"/>
-            <a:ext cx="2997200" cy="825500"/>
+            <a:off x="1447800" y="5969000"/>
+            <a:ext cx="4191000" cy="533400"/>
           </a:xfrm>
           <a:prstGeom prst="rect">
             <a:avLst/>
@@ -3999,7 +4045,7 @@
           <a:noFill/>
         </p:spPr>
         <p:txBody>
-          <a:bodyPr wrap="square" anchor="t" lIns="0" rIns="0" tIns="0" bIns="0">
+          <a:bodyPr wrap="square" anchor="ctr" lIns="0" rIns="0" tIns="0" bIns="0">
             <a:spAutoFit/>
           </a:bodyPr>
           <a:lstStyle/>
@@ -4019,14 +4065,37 @@
               <a:t>Formatieve feedback van 50% naar 100%</a:t>
             </a:r>
           </a:p>
+        </p:txBody>
+      </p:sp>
+      <p:sp>
+        <p:nvSpPr>
+          <p:cNvPr id="25" name="TextBox 24"/>
+          <p:cNvSpPr txBox="1"/>
+          <p:nvPr/>
+        </p:nvSpPr>
+        <p:spPr>
+          <a:xfrm>
+            <a:off x="5778500" y="5969000"/>
+            <a:ext cx="5461000" cy="533400"/>
+          </a:xfrm>
+          <a:prstGeom prst="rect">
+            <a:avLst/>
+          </a:prstGeom>
+          <a:noFill/>
+        </p:spPr>
+        <p:txBody>
+          <a:bodyPr wrap="square" anchor="ctr" lIns="0" rIns="0" tIns="0" bIns="0">
+            <a:spAutoFit/>
+          </a:bodyPr>
+          <a:lstStyle/>
           <a:p>
             <a:pPr>
               <a:spcBef>
-                <a:spcPts val="400"/>
+                <a:spcPts val="0"/>
               </a:spcBef>
             </a:pPr>
             <a:r>
-              <a:rPr sz="1200" b="0">
+              <a:rPr sz="1300" b="0">
                 <a:solidFill>
                   <a:srgbClr val="1D2433"/>
                 </a:solidFill>

</xml_diff>

<commit_message>
Business case: prijspagina met grotere voordeelkaarten
Co-Authored-By: Claude Opus 5.5 <noreply@anthropic.com>
Claude-Session: https://claude.ai/code/session_01N8nwrWExSKGjo2t8Td3eSo
</commit_message>
<xml_diff>
--- a/GTM/Knowledge/business-case/pptx/prijs-bewerkbaar.pptx
+++ b/GTM/Knowledge/business-case/pptx/prijs-bewerkbaar.pptx
@@ -3174,12 +3174,12 @@
         </p:nvSpPr>
         <p:spPr>
           <a:xfrm>
-            <a:off x="762000" y="1333500"/>
-            <a:ext cx="10668000" cy="2032000"/>
+            <a:off x="762000" y="1206500"/>
+            <a:ext cx="10668000" cy="1778000"/>
           </a:xfrm>
           <a:prstGeom prst="roundRect">
             <a:avLst>
-              <a:gd name="adj" fmla="val 7000"/>
+              <a:gd name="adj" fmla="val 8000"/>
             </a:avLst>
           </a:prstGeom>
           <a:solidFill>
@@ -3220,8 +3220,8 @@
         </p:nvSpPr>
         <p:spPr>
           <a:xfrm>
-            <a:off x="1333500" y="1333500"/>
-            <a:ext cx="9525000" cy="2032000"/>
+            <a:off x="1206500" y="1206500"/>
+            <a:ext cx="4826000" cy="1778000"/>
           </a:xfrm>
           <a:prstGeom prst="rect">
             <a:avLst/>
@@ -3240,7 +3240,7 @@
               </a:spcBef>
             </a:pPr>
             <a:r>
-              <a:rPr sz="6800" b="1">
+              <a:rPr sz="5600" b="1">
                 <a:solidFill>
                   <a:srgbClr val="FFFFFF"/>
                 </a:solidFill>
@@ -3252,11 +3252,11 @@
           <a:p>
             <a:pPr>
               <a:spcBef>
-                <a:spcPts val="800"/>
+                <a:spcPts val="600"/>
               </a:spcBef>
             </a:pPr>
             <a:r>
-              <a:rPr sz="2000" b="0">
+              <a:rPr sz="1800" b="0">
                 <a:solidFill>
                   <a:srgbClr val="FFFFFF"/>
                 </a:solidFill>
@@ -3272,7 +3272,7 @@
               </a:spcBef>
             </a:pPr>
             <a:r>
-              <a:rPr sz="1400" b="0">
+              <a:rPr sz="1300" b="0">
                 <a:solidFill>
                   <a:srgbClr val="C9CED9"/>
                 </a:solidFill>
@@ -3283,20 +3283,181 @@
           </a:p>
         </p:txBody>
       </p:sp>
-      <p:sp>
-        <p:nvSpPr>
-          <p:cNvPr id="6" name="Rounded Rectangle 5"/>
+      <p:cxnSp>
+        <p:nvCxnSpPr>
+          <p:cNvPr id="6" name="Connector 5"/>
+          <p:cNvCxnSpPr/>
+          <p:nvPr/>
+        </p:nvCxnSpPr>
+        <p:spPr>
+          <a:xfrm>
+            <a:off x="6477000" y="1485900"/>
+            <a:ext cx="0" cy="1219200"/>
+          </a:xfrm>
+          <a:prstGeom prst="line">
+            <a:avLst/>
+          </a:prstGeom>
+          <a:ln w="12700">
+            <a:solidFill>
+              <a:srgbClr val="3A4566"/>
+            </a:solidFill>
+          </a:ln>
+        </p:spPr>
+        <p:style>
+          <a:lnRef idx="2">
+            <a:schemeClr val="accent1"/>
+          </a:lnRef>
+          <a:fillRef idx="0">
+            <a:schemeClr val="accent1"/>
+          </a:fillRef>
+          <a:effectRef idx="1">
+            <a:schemeClr val="accent1"/>
+          </a:effectRef>
+          <a:fontRef idx="minor">
+            <a:schemeClr val="tx1"/>
+          </a:fontRef>
+        </p:style>
+      </p:cxnSp>
+      <p:sp>
+        <p:nvSpPr>
+          <p:cNvPr id="7" name="TextBox 6"/>
+          <p:cNvSpPr txBox="1"/>
+          <p:nvPr/>
+        </p:nvSpPr>
+        <p:spPr>
+          <a:xfrm>
+            <a:off x="6858000" y="1206500"/>
+            <a:ext cx="4191000" cy="1778000"/>
+          </a:xfrm>
+          <a:prstGeom prst="rect">
+            <a:avLst/>
+          </a:prstGeom>
+          <a:noFill/>
+        </p:spPr>
+        <p:txBody>
+          <a:bodyPr wrap="square" anchor="ctr" lIns="0" rIns="0" tIns="0" bIns="0">
+            <a:spAutoFit/>
+          </a:bodyPr>
+          <a:lstStyle/>
+          <a:p>
+            <a:pPr>
+              <a:spcBef>
+                <a:spcPts val="0"/>
+              </a:spcBef>
+            </a:pPr>
+            <a:r>
+              <a:rPr sz="1600" b="1">
+                <a:solidFill>
+                  <a:srgbClr val="FFFFFF"/>
+                </a:solidFill>
+                <a:latin typeface="Inter"/>
+              </a:rPr>
+              <a:t>Eerste 400 studenten</a:t>
+            </a:r>
+          </a:p>
+          <a:p>
+            <a:pPr>
+              <a:spcBef>
+                <a:spcPts val="200"/>
+              </a:spcBef>
+            </a:pPr>
+            <a:r>
+              <a:rPr sz="1300" b="0">
+                <a:solidFill>
+                  <a:srgbClr val="C9CED9"/>
+                </a:solidFill>
+                <a:latin typeface="Inter"/>
+              </a:rPr>
+              <a:t>€ 3,75 per student per maand, samen € 1.500</a:t>
+            </a:r>
+          </a:p>
+          <a:p>
+            <a:pPr>
+              <a:spcBef>
+                <a:spcPts val="1800"/>
+              </a:spcBef>
+            </a:pPr>
+            <a:r>
+              <a:rPr sz="1600" b="1">
+                <a:solidFill>
+                  <a:srgbClr val="FFFFFF"/>
+                </a:solidFill>
+                <a:latin typeface="Inter"/>
+              </a:rPr>
+              <a:t>Elke student daarboven</a:t>
+            </a:r>
+          </a:p>
+          <a:p>
+            <a:pPr>
+              <a:spcBef>
+                <a:spcPts val="200"/>
+              </a:spcBef>
+            </a:pPr>
+            <a:r>
+              <a:rPr sz="1300" b="0">
+                <a:solidFill>
+                  <a:srgbClr val="C9CED9"/>
+                </a:solidFill>
+                <a:latin typeface="Inter"/>
+              </a:rPr>
+              <a:t>€ 3 per student per maand</a:t>
+            </a:r>
+          </a:p>
+        </p:txBody>
+      </p:sp>
+      <p:sp>
+        <p:nvSpPr>
+          <p:cNvPr id="8" name="TextBox 7"/>
+          <p:cNvSpPr txBox="1"/>
+          <p:nvPr/>
+        </p:nvSpPr>
+        <p:spPr>
+          <a:xfrm>
+            <a:off x="762000" y="3175000"/>
+            <a:ext cx="10668000" cy="190500"/>
+          </a:xfrm>
+          <a:prstGeom prst="rect">
+            <a:avLst/>
+          </a:prstGeom>
+          <a:noFill/>
+        </p:spPr>
+        <p:txBody>
+          <a:bodyPr wrap="square" anchor="t" lIns="0" rIns="0" tIns="0" bIns="0">
+            <a:spAutoFit/>
+          </a:bodyPr>
+          <a:lstStyle/>
+          <a:p>
+            <a:pPr>
+              <a:spcBef>
+                <a:spcPts val="0"/>
+              </a:spcBef>
+            </a:pPr>
+            <a:r>
+              <a:rPr sz="1100" b="1">
+                <a:solidFill>
+                  <a:srgbClr val="0B1533"/>
+                </a:solidFill>
+                <a:latin typeface="Inter"/>
+              </a:rPr>
+              <a:t>WAT DE INSTELLING ERVOOR KRIJGT</a:t>
+            </a:r>
+          </a:p>
+        </p:txBody>
+      </p:sp>
+      <p:sp>
+        <p:nvSpPr>
+          <p:cNvPr id="9" name="Rounded Rectangle 8"/>
           <p:cNvSpPr/>
           <p:nvPr/>
         </p:nvSpPr>
         <p:spPr>
           <a:xfrm>
-            <a:off x="762000" y="3479800"/>
-            <a:ext cx="5257800" cy="787400"/>
+            <a:off x="762000" y="3416300"/>
+            <a:ext cx="10668000" cy="952500"/>
           </a:xfrm>
           <a:prstGeom prst="roundRect">
             <a:avLst>
-              <a:gd name="adj" fmla="val 12000"/>
+              <a:gd name="adj" fmla="val 14000"/>
             </a:avLst>
           </a:prstGeom>
           <a:solidFill>
@@ -3331,14 +3492,82 @@
       </p:sp>
       <p:sp>
         <p:nvSpPr>
-          <p:cNvPr id="7" name="TextBox 6"/>
+          <p:cNvPr id="10" name="Oval 9"/>
+          <p:cNvSpPr/>
+          <p:nvPr/>
+        </p:nvSpPr>
+        <p:spPr>
+          <a:xfrm>
+            <a:off x="1016000" y="3587750"/>
+            <a:ext cx="609600" cy="609600"/>
+          </a:xfrm>
+          <a:prstGeom prst="ellipse">
+            <a:avLst/>
+          </a:prstGeom>
+          <a:solidFill>
+            <a:srgbClr val="FFFFFF"/>
+          </a:solidFill>
+          <a:ln>
+            <a:noFill/>
+          </a:ln>
+          <a:effectLst/>
+        </p:spPr>
+        <p:style>
+          <a:lnRef idx="1">
+            <a:schemeClr val="accent1"/>
+          </a:lnRef>
+          <a:fillRef idx="3">
+            <a:schemeClr val="accent1"/>
+          </a:fillRef>
+          <a:effectRef idx="2">
+            <a:schemeClr val="accent1"/>
+          </a:effectRef>
+          <a:fontRef idx="minor">
+            <a:schemeClr val="lt1"/>
+          </a:fontRef>
+        </p:style>
+        <p:txBody>
+          <a:bodyPr rtlCol="0" anchor="ctr"/>
+          <a:lstStyle/>
+          <a:p>
+            <a:pPr algn="ctr"/>
+          </a:p>
+        </p:txBody>
+      </p:sp>
+      <p:pic>
+        <p:nvPicPr>
+          <p:cNvPr id="11" name="Picture 10" descr="consistent.png"/>
+          <p:cNvPicPr>
+            <a:picLocks noChangeAspect="1"/>
+          </p:cNvPicPr>
+          <p:nvPr/>
+        </p:nvPicPr>
+        <p:blipFill>
+          <a:blip r:embed="rId2"/>
+          <a:stretch>
+            <a:fillRect/>
+          </a:stretch>
+        </p:blipFill>
+        <p:spPr>
+          <a:xfrm>
+            <a:off x="1168400" y="3740150"/>
+            <a:ext cx="304800" cy="304800"/>
+          </a:xfrm>
+          <a:prstGeom prst="rect">
+            <a:avLst/>
+          </a:prstGeom>
+        </p:spPr>
+      </p:pic>
+      <p:sp>
+        <p:nvSpPr>
+          <p:cNvPr id="12" name="TextBox 11"/>
           <p:cNvSpPr txBox="1"/>
           <p:nvPr/>
         </p:nvSpPr>
         <p:spPr>
           <a:xfrm>
-            <a:off x="1041400" y="3479800"/>
-            <a:ext cx="4699000" cy="787400"/>
+            <a:off x="1879600" y="3416300"/>
+            <a:ext cx="9271000" cy="952500"/>
           </a:xfrm>
           <a:prstGeom prst="rect">
             <a:avLst/>
@@ -3357,47 +3586,47 @@
               </a:spcBef>
             </a:pPr>
             <a:r>
-              <a:rPr sz="1800" b="1">
-                <a:solidFill>
-                  <a:srgbClr val="0B1533"/>
-                </a:solidFill>
-                <a:latin typeface="Inter"/>
-              </a:rPr>
-              <a:t>Eerste 400 studenten</a:t>
-            </a:r>
-          </a:p>
-          <a:p>
-            <a:pPr>
-              <a:spcBef>
-                <a:spcPts val="400"/>
-              </a:spcBef>
-            </a:pPr>
-            <a:r>
-              <a:rPr sz="1300" b="0">
+              <a:rPr sz="2000" b="1">
                 <a:solidFill>
                   <a:srgbClr val="1D2433"/>
                 </a:solidFill>
                 <a:latin typeface="Inter"/>
               </a:rPr>
-              <a:t>€ 3,75 per student per maand, samen € 1.500</a:t>
-            </a:r>
-          </a:p>
-        </p:txBody>
-      </p:sp>
-      <p:sp>
-        <p:nvSpPr>
-          <p:cNvPr id="8" name="Rounded Rectangle 7"/>
+              <a:t>Uniforme beoordeling</a:t>
+            </a:r>
+          </a:p>
+          <a:p>
+            <a:pPr>
+              <a:spcBef>
+                <a:spcPts val="600"/>
+              </a:spcBef>
+            </a:pPr>
+            <a:r>
+              <a:rPr sz="1400" b="0">
+                <a:solidFill>
+                  <a:srgbClr val="1D2433"/>
+                </a:solidFill>
+                <a:latin typeface="Inter"/>
+              </a:rPr>
+              <a:t>Elke opdracht wordt langs dezelfde criteria beoordeeld, door elke beoordelaar.</a:t>
+            </a:r>
+          </a:p>
+        </p:txBody>
+      </p:sp>
+      <p:sp>
+        <p:nvSpPr>
+          <p:cNvPr id="13" name="Rounded Rectangle 12"/>
           <p:cNvSpPr/>
           <p:nvPr/>
         </p:nvSpPr>
         <p:spPr>
           <a:xfrm>
-            <a:off x="6172200" y="3479800"/>
-            <a:ext cx="5257800" cy="787400"/>
+            <a:off x="762000" y="4470400"/>
+            <a:ext cx="10668000" cy="952500"/>
           </a:xfrm>
           <a:prstGeom prst="roundRect">
             <a:avLst>
-              <a:gd name="adj" fmla="val 12000"/>
+              <a:gd name="adj" fmla="val 14000"/>
             </a:avLst>
           </a:prstGeom>
           <a:solidFill>
@@ -3432,121 +3661,23 @@
       </p:sp>
       <p:sp>
         <p:nvSpPr>
-          <p:cNvPr id="9" name="TextBox 8"/>
-          <p:cNvSpPr txBox="1"/>
+          <p:cNvPr id="14" name="Oval 13"/>
+          <p:cNvSpPr/>
           <p:nvPr/>
         </p:nvSpPr>
         <p:spPr>
           <a:xfrm>
-            <a:off x="6451600" y="3479800"/>
-            <a:ext cx="4699000" cy="787400"/>
+            <a:off x="1016000" y="4641850"/>
+            <a:ext cx="609600" cy="609600"/>
           </a:xfrm>
-          <a:prstGeom prst="rect">
+          <a:prstGeom prst="ellipse">
             <a:avLst/>
-          </a:prstGeom>
-          <a:noFill/>
-        </p:spPr>
-        <p:txBody>
-          <a:bodyPr wrap="square" anchor="ctr" lIns="0" rIns="0" tIns="0" bIns="0">
-            <a:spAutoFit/>
-          </a:bodyPr>
-          <a:lstStyle/>
-          <a:p>
-            <a:pPr>
-              <a:spcBef>
-                <a:spcPts val="0"/>
-              </a:spcBef>
-            </a:pPr>
-            <a:r>
-              <a:rPr sz="1800" b="1">
-                <a:solidFill>
-                  <a:srgbClr val="0B1533"/>
-                </a:solidFill>
-                <a:latin typeface="Inter"/>
-              </a:rPr>
-              <a:t>Elke student daarboven</a:t>
-            </a:r>
-          </a:p>
-          <a:p>
-            <a:pPr>
-              <a:spcBef>
-                <a:spcPts val="400"/>
-              </a:spcBef>
-            </a:pPr>
-            <a:r>
-              <a:rPr sz="1300" b="0">
-                <a:solidFill>
-                  <a:srgbClr val="1D2433"/>
-                </a:solidFill>
-                <a:latin typeface="Inter"/>
-              </a:rPr>
-              <a:t>€ 3 per student per maand</a:t>
-            </a:r>
-          </a:p>
-        </p:txBody>
-      </p:sp>
-      <p:sp>
-        <p:nvSpPr>
-          <p:cNvPr id="10" name="TextBox 9"/>
-          <p:cNvSpPr txBox="1"/>
-          <p:nvPr/>
-        </p:nvSpPr>
-        <p:spPr>
-          <a:xfrm>
-            <a:off x="762000" y="4521200"/>
-            <a:ext cx="10668000" cy="190500"/>
-          </a:xfrm>
-          <a:prstGeom prst="rect">
-            <a:avLst/>
-          </a:prstGeom>
-          <a:noFill/>
-        </p:spPr>
-        <p:txBody>
-          <a:bodyPr wrap="square" anchor="t" lIns="0" rIns="0" tIns="0" bIns="0">
-            <a:spAutoFit/>
-          </a:bodyPr>
-          <a:lstStyle/>
-          <a:p>
-            <a:pPr>
-              <a:spcBef>
-                <a:spcPts val="0"/>
-              </a:spcBef>
-            </a:pPr>
-            <a:r>
-              <a:rPr sz="1100" b="1">
-                <a:solidFill>
-                  <a:srgbClr val="0B1533"/>
-                </a:solidFill>
-                <a:latin typeface="Inter"/>
-              </a:rPr>
-              <a:t>WAT DE INSTELLING ERVOOR KRIJGT</a:t>
-            </a:r>
-          </a:p>
-        </p:txBody>
-      </p:sp>
-      <p:sp>
-        <p:nvSpPr>
-          <p:cNvPr id="11" name="Rounded Rectangle 10"/>
-          <p:cNvSpPr/>
-          <p:nvPr/>
-        </p:nvSpPr>
-        <p:spPr>
-          <a:xfrm>
-            <a:off x="762000" y="4749800"/>
-            <a:ext cx="10668000" cy="533400"/>
-          </a:xfrm>
-          <a:prstGeom prst="roundRect">
-            <a:avLst>
-              <a:gd name="adj" fmla="val 18000"/>
-            </a:avLst>
           </a:prstGeom>
           <a:solidFill>
             <a:srgbClr val="FFFFFF"/>
           </a:solidFill>
-          <a:ln w="12700">
-            <a:solidFill>
-              <a:srgbClr val="D9DDE4"/>
-            </a:solidFill>
+          <a:ln>
+            <a:noFill/>
           </a:ln>
           <a:effectLst/>
         </p:spPr>
@@ -3572,19 +3703,100 @@
           </a:p>
         </p:txBody>
       </p:sp>
-      <p:sp>
-        <p:nvSpPr>
-          <p:cNvPr id="12" name="Oval 11"/>
+      <p:pic>
+        <p:nvPicPr>
+          <p:cNvPr id="15" name="Picture 14" descr="koppeling.png"/>
+          <p:cNvPicPr>
+            <a:picLocks noChangeAspect="1"/>
+          </p:cNvPicPr>
+          <p:nvPr/>
+        </p:nvPicPr>
+        <p:blipFill>
+          <a:blip r:embed="rId3"/>
+          <a:stretch>
+            <a:fillRect/>
+          </a:stretch>
+        </p:blipFill>
+        <p:spPr>
+          <a:xfrm>
+            <a:off x="1168400" y="4794250"/>
+            <a:ext cx="304800" cy="304800"/>
+          </a:xfrm>
+          <a:prstGeom prst="rect">
+            <a:avLst/>
+          </a:prstGeom>
+        </p:spPr>
+      </p:pic>
+      <p:sp>
+        <p:nvSpPr>
+          <p:cNvPr id="16" name="TextBox 15"/>
+          <p:cNvSpPr txBox="1"/>
+          <p:nvPr/>
+        </p:nvSpPr>
+        <p:spPr>
+          <a:xfrm>
+            <a:off x="1879600" y="4470400"/>
+            <a:ext cx="9271000" cy="952500"/>
+          </a:xfrm>
+          <a:prstGeom prst="rect">
+            <a:avLst/>
+          </a:prstGeom>
+          <a:noFill/>
+        </p:spPr>
+        <p:txBody>
+          <a:bodyPr wrap="square" anchor="ctr" lIns="0" rIns="0" tIns="0" bIns="0">
+            <a:spAutoFit/>
+          </a:bodyPr>
+          <a:lstStyle/>
+          <a:p>
+            <a:pPr>
+              <a:spcBef>
+                <a:spcPts val="0"/>
+              </a:spcBef>
+            </a:pPr>
+            <a:r>
+              <a:rPr sz="2000" b="1">
+                <a:solidFill>
+                  <a:srgbClr val="1D2433"/>
+                </a:solidFill>
+                <a:latin typeface="Inter"/>
+              </a:rPr>
+              <a:t>Integratie in NEO LMS</a:t>
+            </a:r>
+          </a:p>
+          <a:p>
+            <a:pPr>
+              <a:spcBef>
+                <a:spcPts val="600"/>
+              </a:spcBef>
+            </a:pPr>
+            <a:r>
+              <a:rPr sz="1400" b="0">
+                <a:solidFill>
+                  <a:srgbClr val="1D2433"/>
+                </a:solidFill>
+                <a:latin typeface="Inter"/>
+              </a:rPr>
+              <a:t>Opdrachten en cijfers lopen via NEO. Docenten en studenten werken in de omgeving die ze kennen.</a:t>
+            </a:r>
+          </a:p>
+        </p:txBody>
+      </p:sp>
+      <p:sp>
+        <p:nvSpPr>
+          <p:cNvPr id="17" name="Rounded Rectangle 16"/>
           <p:cNvSpPr/>
           <p:nvPr/>
         </p:nvSpPr>
         <p:spPr>
           <a:xfrm>
-            <a:off x="914400" y="4838700"/>
-            <a:ext cx="355600" cy="355600"/>
+            <a:off x="762000" y="5524500"/>
+            <a:ext cx="10668000" cy="952500"/>
           </a:xfrm>
-          <a:prstGeom prst="ellipse">
-            <a:avLst/>
+          <a:prstGeom prst="roundRect">
+            <a:avLst>
+              <a:gd name="adj" fmla="val 14000"/>
+            </a:avLst>
           </a:prstGeom>
           <a:solidFill>
             <a:srgbClr val="EEF1F7"/>
@@ -3616,172 +3828,22 @@
           </a:p>
         </p:txBody>
       </p:sp>
-      <p:pic>
-        <p:nvPicPr>
-          <p:cNvPr id="13" name="Picture 12" descr="consistent.png"/>
-          <p:cNvPicPr>
-            <a:picLocks noChangeAspect="1"/>
-          </p:cNvPicPr>
+      <p:sp>
+        <p:nvSpPr>
+          <p:cNvPr id="18" name="Oval 17"/>
+          <p:cNvSpPr/>
           <p:nvPr/>
-        </p:nvPicPr>
-        <p:blipFill>
-          <a:blip r:embed="rId2"/>
-          <a:stretch>
-            <a:fillRect/>
-          </a:stretch>
-        </p:blipFill>
+        </p:nvSpPr>
         <p:spPr>
           <a:xfrm>
-            <a:off x="1003300" y="4927600"/>
-            <a:ext cx="177800" cy="177800"/>
-          </a:xfrm>
-          <a:prstGeom prst="rect">
-            <a:avLst/>
-          </a:prstGeom>
-        </p:spPr>
-      </p:pic>
-      <p:sp>
-        <p:nvSpPr>
-          <p:cNvPr id="14" name="TextBox 13"/>
-          <p:cNvSpPr txBox="1"/>
-          <p:nvPr/>
-        </p:nvSpPr>
-        <p:spPr>
-          <a:xfrm>
-            <a:off x="1447800" y="4749800"/>
-            <a:ext cx="4191000" cy="533400"/>
-          </a:xfrm>
-          <a:prstGeom prst="rect">
-            <a:avLst/>
-          </a:prstGeom>
-          <a:noFill/>
-        </p:spPr>
-        <p:txBody>
-          <a:bodyPr wrap="square" anchor="ctr" lIns="0" rIns="0" tIns="0" bIns="0">
-            <a:spAutoFit/>
-          </a:bodyPr>
-          <a:lstStyle/>
-          <a:p>
-            <a:pPr>
-              <a:spcBef>
-                <a:spcPts val="0"/>
-              </a:spcBef>
-            </a:pPr>
-            <a:r>
-              <a:rPr sz="1600" b="1">
-                <a:solidFill>
-                  <a:srgbClr val="1D2433"/>
-                </a:solidFill>
-                <a:latin typeface="Inter"/>
-              </a:rPr>
-              <a:t>Uniforme beoordeling</a:t>
-            </a:r>
-          </a:p>
-        </p:txBody>
-      </p:sp>
-      <p:sp>
-        <p:nvSpPr>
-          <p:cNvPr id="15" name="TextBox 14"/>
-          <p:cNvSpPr txBox="1"/>
-          <p:nvPr/>
-        </p:nvSpPr>
-        <p:spPr>
-          <a:xfrm>
-            <a:off x="5778500" y="4749800"/>
-            <a:ext cx="5461000" cy="533400"/>
-          </a:xfrm>
-          <a:prstGeom prst="rect">
-            <a:avLst/>
-          </a:prstGeom>
-          <a:noFill/>
-        </p:spPr>
-        <p:txBody>
-          <a:bodyPr wrap="square" anchor="ctr" lIns="0" rIns="0" tIns="0" bIns="0">
-            <a:spAutoFit/>
-          </a:bodyPr>
-          <a:lstStyle/>
-          <a:p>
-            <a:pPr>
-              <a:spcBef>
-                <a:spcPts val="0"/>
-              </a:spcBef>
-            </a:pPr>
-            <a:r>
-              <a:rPr sz="1300" b="0">
-                <a:solidFill>
-                  <a:srgbClr val="1D2433"/>
-                </a:solidFill>
-                <a:latin typeface="Inter"/>
-              </a:rPr>
-              <a:t>Elke opdracht wordt langs dezelfde criteria beoordeeld, door elke beoordelaar.</a:t>
-            </a:r>
-          </a:p>
-        </p:txBody>
-      </p:sp>
-      <p:sp>
-        <p:nvSpPr>
-          <p:cNvPr id="16" name="Rounded Rectangle 15"/>
-          <p:cNvSpPr/>
-          <p:nvPr/>
-        </p:nvSpPr>
-        <p:spPr>
-          <a:xfrm>
-            <a:off x="762000" y="5359400"/>
-            <a:ext cx="10668000" cy="533400"/>
-          </a:xfrm>
-          <a:prstGeom prst="roundRect">
-            <a:avLst>
-              <a:gd name="adj" fmla="val 18000"/>
-            </a:avLst>
-          </a:prstGeom>
-          <a:solidFill>
-            <a:srgbClr val="FFFFFF"/>
-          </a:solidFill>
-          <a:ln w="12700">
-            <a:solidFill>
-              <a:srgbClr val="D9DDE4"/>
-            </a:solidFill>
-          </a:ln>
-          <a:effectLst/>
-        </p:spPr>
-        <p:style>
-          <a:lnRef idx="1">
-            <a:schemeClr val="accent1"/>
-          </a:lnRef>
-          <a:fillRef idx="3">
-            <a:schemeClr val="accent1"/>
-          </a:fillRef>
-          <a:effectRef idx="2">
-            <a:schemeClr val="accent1"/>
-          </a:effectRef>
-          <a:fontRef idx="minor">
-            <a:schemeClr val="lt1"/>
-          </a:fontRef>
-        </p:style>
-        <p:txBody>
-          <a:bodyPr rtlCol="0" anchor="ctr"/>
-          <a:lstStyle/>
-          <a:p>
-            <a:pPr algn="ctr"/>
-          </a:p>
-        </p:txBody>
-      </p:sp>
-      <p:sp>
-        <p:nvSpPr>
-          <p:cNvPr id="17" name="Oval 16"/>
-          <p:cNvSpPr/>
-          <p:nvPr/>
-        </p:nvSpPr>
-        <p:spPr>
-          <a:xfrm>
-            <a:off x="914400" y="5448300"/>
-            <a:ext cx="355600" cy="355600"/>
+            <a:off x="1016000" y="5695950"/>
+            <a:ext cx="609600" cy="609600"/>
           </a:xfrm>
           <a:prstGeom prst="ellipse">
             <a:avLst/>
           </a:prstGeom>
           <a:solidFill>
-            <a:srgbClr val="EEF1F7"/>
+            <a:srgbClr val="FFFFFF"/>
           </a:solidFill>
           <a:ln>
             <a:noFill/>
@@ -3812,201 +3874,7 @@
       </p:sp>
       <p:pic>
         <p:nvPicPr>
-          <p:cNvPr id="18" name="Picture 17" descr="koppeling.png"/>
-          <p:cNvPicPr>
-            <a:picLocks noChangeAspect="1"/>
-          </p:cNvPicPr>
-          <p:nvPr/>
-        </p:nvPicPr>
-        <p:blipFill>
-          <a:blip r:embed="rId3"/>
-          <a:stretch>
-            <a:fillRect/>
-          </a:stretch>
-        </p:blipFill>
-        <p:spPr>
-          <a:xfrm>
-            <a:off x="1003300" y="5537200"/>
-            <a:ext cx="177800" cy="177800"/>
-          </a:xfrm>
-          <a:prstGeom prst="rect">
-            <a:avLst/>
-          </a:prstGeom>
-        </p:spPr>
-      </p:pic>
-      <p:sp>
-        <p:nvSpPr>
-          <p:cNvPr id="19" name="TextBox 18"/>
-          <p:cNvSpPr txBox="1"/>
-          <p:nvPr/>
-        </p:nvSpPr>
-        <p:spPr>
-          <a:xfrm>
-            <a:off x="1447800" y="5359400"/>
-            <a:ext cx="4191000" cy="533400"/>
-          </a:xfrm>
-          <a:prstGeom prst="rect">
-            <a:avLst/>
-          </a:prstGeom>
-          <a:noFill/>
-        </p:spPr>
-        <p:txBody>
-          <a:bodyPr wrap="square" anchor="ctr" lIns="0" rIns="0" tIns="0" bIns="0">
-            <a:spAutoFit/>
-          </a:bodyPr>
-          <a:lstStyle/>
-          <a:p>
-            <a:pPr>
-              <a:spcBef>
-                <a:spcPts val="0"/>
-              </a:spcBef>
-            </a:pPr>
-            <a:r>
-              <a:rPr sz="1600" b="1">
-                <a:solidFill>
-                  <a:srgbClr val="1D2433"/>
-                </a:solidFill>
-                <a:latin typeface="Inter"/>
-              </a:rPr>
-              <a:t>Integratie in NEO LMS</a:t>
-            </a:r>
-          </a:p>
-        </p:txBody>
-      </p:sp>
-      <p:sp>
-        <p:nvSpPr>
-          <p:cNvPr id="20" name="TextBox 19"/>
-          <p:cNvSpPr txBox="1"/>
-          <p:nvPr/>
-        </p:nvSpPr>
-        <p:spPr>
-          <a:xfrm>
-            <a:off x="5778500" y="5359400"/>
-            <a:ext cx="5461000" cy="533400"/>
-          </a:xfrm>
-          <a:prstGeom prst="rect">
-            <a:avLst/>
-          </a:prstGeom>
-          <a:noFill/>
-        </p:spPr>
-        <p:txBody>
-          <a:bodyPr wrap="square" anchor="ctr" lIns="0" rIns="0" tIns="0" bIns="0">
-            <a:spAutoFit/>
-          </a:bodyPr>
-          <a:lstStyle/>
-          <a:p>
-            <a:pPr>
-              <a:spcBef>
-                <a:spcPts val="0"/>
-              </a:spcBef>
-            </a:pPr>
-            <a:r>
-              <a:rPr sz="1300" b="0">
-                <a:solidFill>
-                  <a:srgbClr val="1D2433"/>
-                </a:solidFill>
-                <a:latin typeface="Inter"/>
-              </a:rPr>
-              <a:t>Opdrachten en cijfers lopen via NEO. Docenten en studenten werken in de omgeving die ze kennen.</a:t>
-            </a:r>
-          </a:p>
-        </p:txBody>
-      </p:sp>
-      <p:sp>
-        <p:nvSpPr>
-          <p:cNvPr id="21" name="Rounded Rectangle 20"/>
-          <p:cNvSpPr/>
-          <p:nvPr/>
-        </p:nvSpPr>
-        <p:spPr>
-          <a:xfrm>
-            <a:off x="762000" y="5969000"/>
-            <a:ext cx="10668000" cy="533400"/>
-          </a:xfrm>
-          <a:prstGeom prst="roundRect">
-            <a:avLst>
-              <a:gd name="adj" fmla="val 18000"/>
-            </a:avLst>
-          </a:prstGeom>
-          <a:solidFill>
-            <a:srgbClr val="FFFFFF"/>
-          </a:solidFill>
-          <a:ln w="12700">
-            <a:solidFill>
-              <a:srgbClr val="D9DDE4"/>
-            </a:solidFill>
-          </a:ln>
-          <a:effectLst/>
-        </p:spPr>
-        <p:style>
-          <a:lnRef idx="1">
-            <a:schemeClr val="accent1"/>
-          </a:lnRef>
-          <a:fillRef idx="3">
-            <a:schemeClr val="accent1"/>
-          </a:fillRef>
-          <a:effectRef idx="2">
-            <a:schemeClr val="accent1"/>
-          </a:effectRef>
-          <a:fontRef idx="minor">
-            <a:schemeClr val="lt1"/>
-          </a:fontRef>
-        </p:style>
-        <p:txBody>
-          <a:bodyPr rtlCol="0" anchor="ctr"/>
-          <a:lstStyle/>
-          <a:p>
-            <a:pPr algn="ctr"/>
-          </a:p>
-        </p:txBody>
-      </p:sp>
-      <p:sp>
-        <p:nvSpPr>
-          <p:cNvPr id="22" name="Oval 21"/>
-          <p:cNvSpPr/>
-          <p:nvPr/>
-        </p:nvSpPr>
-        <p:spPr>
-          <a:xfrm>
-            <a:off x="914400" y="6057900"/>
-            <a:ext cx="355600" cy="355600"/>
-          </a:xfrm>
-          <a:prstGeom prst="ellipse">
-            <a:avLst/>
-          </a:prstGeom>
-          <a:solidFill>
-            <a:srgbClr val="EEF1F7"/>
-          </a:solidFill>
-          <a:ln>
-            <a:noFill/>
-          </a:ln>
-          <a:effectLst/>
-        </p:spPr>
-        <p:style>
-          <a:lnRef idx="1">
-            <a:schemeClr val="accent1"/>
-          </a:lnRef>
-          <a:fillRef idx="3">
-            <a:schemeClr val="accent1"/>
-          </a:fillRef>
-          <a:effectRef idx="2">
-            <a:schemeClr val="accent1"/>
-          </a:effectRef>
-          <a:fontRef idx="minor">
-            <a:schemeClr val="lt1"/>
-          </a:fontRef>
-        </p:style>
-        <p:txBody>
-          <a:bodyPr rtlCol="0" anchor="ctr"/>
-          <a:lstStyle/>
-          <a:p>
-            <a:pPr algn="ctr"/>
-          </a:p>
-        </p:txBody>
-      </p:sp>
-      <p:pic>
-        <p:nvPicPr>
-          <p:cNvPr id="23" name="Picture 22" descr="feedback.png"/>
+          <p:cNvPr id="19" name="Picture 18" descr="feedback.png"/>
           <p:cNvPicPr>
             <a:picLocks noChangeAspect="1"/>
           </p:cNvPicPr>
@@ -4020,8 +3888,8 @@
         </p:blipFill>
         <p:spPr>
           <a:xfrm>
-            <a:off x="1003300" y="6146800"/>
-            <a:ext cx="177800" cy="177800"/>
+            <a:off x="1168400" y="5848350"/>
+            <a:ext cx="304800" cy="304800"/>
           </a:xfrm>
           <a:prstGeom prst="rect">
             <a:avLst/>
@@ -4030,14 +3898,14 @@
       </p:pic>
       <p:sp>
         <p:nvSpPr>
-          <p:cNvPr id="24" name="TextBox 23"/>
+          <p:cNvPr id="20" name="TextBox 19"/>
           <p:cNvSpPr txBox="1"/>
           <p:nvPr/>
         </p:nvSpPr>
         <p:spPr>
           <a:xfrm>
-            <a:off x="1447800" y="5969000"/>
-            <a:ext cx="4191000" cy="533400"/>
+            <a:off x="1879600" y="5524500"/>
+            <a:ext cx="5715000" cy="952500"/>
           </a:xfrm>
           <a:prstGeom prst="rect">
             <a:avLst/>
@@ -4056,27 +3924,43 @@
               </a:spcBef>
             </a:pPr>
             <a:r>
-              <a:rPr sz="1600" b="1">
+              <a:rPr sz="2000" b="1">
                 <a:solidFill>
                   <a:srgbClr val="1D2433"/>
                 </a:solidFill>
                 <a:latin typeface="Inter"/>
               </a:rPr>
-              <a:t>Formatieve feedback van 50% naar 100%</a:t>
-            </a:r>
-          </a:p>
-        </p:txBody>
-      </p:sp>
-      <p:sp>
-        <p:nvSpPr>
-          <p:cNvPr id="25" name="TextBox 24"/>
+              <a:t>Formatieve feedback voor elke student</a:t>
+            </a:r>
+          </a:p>
+          <a:p>
+            <a:pPr>
+              <a:spcBef>
+                <a:spcPts val="600"/>
+              </a:spcBef>
+            </a:pPr>
+            <a:r>
+              <a:rPr sz="1400" b="0">
+                <a:solidFill>
+                  <a:srgbClr val="1D2433"/>
+                </a:solidFill>
+                <a:latin typeface="Inter"/>
+              </a:rPr>
+              <a:t>Nu krijgt de helft van de studenten formatieve feedback. Met Eduface is dat iedereen.</a:t>
+            </a:r>
+          </a:p>
+        </p:txBody>
+      </p:sp>
+      <p:sp>
+        <p:nvSpPr>
+          <p:cNvPr id="21" name="TextBox 20"/>
           <p:cNvSpPr txBox="1"/>
           <p:nvPr/>
         </p:nvSpPr>
         <p:spPr>
           <a:xfrm>
-            <a:off x="5778500" y="5969000"/>
-            <a:ext cx="5461000" cy="533400"/>
+            <a:off x="7747000" y="5524500"/>
+            <a:ext cx="3429000" cy="952500"/>
           </a:xfrm>
           <a:prstGeom prst="rect">
             <a:avLst/>
@@ -4089,19 +3973,19 @@
           </a:bodyPr>
           <a:lstStyle/>
           <a:p>
-            <a:pPr>
+            <a:pPr algn="r">
               <a:spcBef>
                 <a:spcPts val="0"/>
               </a:spcBef>
             </a:pPr>
             <a:r>
-              <a:rPr sz="1300" b="0">
+              <a:rPr sz="3200" b="1">
                 <a:solidFill>
-                  <a:srgbClr val="1D2433"/>
+                  <a:srgbClr val="0B1533"/>
                 </a:solidFill>
                 <a:latin typeface="Inter"/>
               </a:rPr>
-              <a:t>Elke student krijgt formatieve feedback. Nu is dat de helft.</a:t>
+              <a:t>50% → 100%</a:t>
             </a:r>
           </a:p>
         </p:txBody>

</xml_diff>